<commit_message>
Add a version control evidence slide to the deck
New slide 9 carries the GitHub commit history and repository landing page
captures alongside the headline repository figures, so the deck shows the
same version-control evidence as Chapter 5 of the report.

Co-Authored-By: Claude Opus 5 (1M context) <noreply@anthropic.com>
</commit_message>
<xml_diff>
--- a/Farmer_Groceries_Capstone_Demo.pptx
+++ b/Farmer_Groceries_Capstone_Demo.pptx
@@ -16,6 +16,7 @@
     <p:sldId id="261" r:id="rId7"/>
     <p:sldId id="262" r:id="rId8"/>
     <p:sldId id="263" r:id="rId9"/>
+    <p:sldId id="268" r:id="rId17"/>
     <p:sldId id="264" r:id="rId10"/>
     <p:sldId id="265" r:id="rId11"/>
   </p:sldIdLst>
@@ -5865,6 +5866,236 @@
 </file>
 
 <file path=ppt/slides/slide10.xml><?xml version="1.0" encoding="utf-8"?>
+<p:sld xmlns:a="http://schemas.openxmlformats.org/drawingml/2006/main" xmlns:r="http://schemas.openxmlformats.org/officeDocument/2006/relationships" xmlns:p="http://schemas.openxmlformats.org/presentationml/2006/main">
+  <p:cSld>
+    <p:spTree>
+      <p:nvGrpSpPr>
+        <p:cNvPr id="1" name=""/>
+        <p:cNvGrpSpPr/>
+        <p:nvPr/>
+      </p:nvGrpSpPr>
+      <p:grpSpPr>
+        <a:xfrm>
+          <a:off x="0" y="0"/>
+          <a:ext cx="0" cy="0"/>
+          <a:chOff x="0" y="0"/>
+          <a:chExt cx="0" cy="0"/>
+        </a:xfrm>
+      </p:grpSpPr>
+      <p:sp>
+        <p:nvSpPr>
+          <p:cNvPr id="2" name="Title 1"/>
+          <p:cNvSpPr>
+            <a:spLocks noGrp="1"/>
+          </p:cNvSpPr>
+          <p:nvPr>
+            <p:ph type="title"/>
+          </p:nvPr>
+        </p:nvSpPr>
+        <p:spPr/>
+        <p:txBody>
+          <a:bodyPr/>
+          <a:lstStyle/>
+          <a:p>
+            <a:r>
+              <a:t>Challenges &amp; Limitations</a:t>
+            </a:r>
+          </a:p>
+        </p:txBody>
+      </p:sp>
+      <p:sp>
+        <p:nvSpPr>
+          <p:cNvPr id="3" name="Content Placeholder 2"/>
+          <p:cNvSpPr>
+            <a:spLocks noGrp="1"/>
+          </p:cNvSpPr>
+          <p:nvPr>
+            <p:ph idx="1"/>
+          </p:nvPr>
+        </p:nvSpPr>
+        <p:spPr/>
+        <p:txBody>
+          <a:bodyPr wrap="square">
+            <a:noAutofit/>
+          </a:bodyPr>
+          <a:lstStyle/>
+          <a:p>
+            <a:pPr marL="0" indent="0">
+              <a:spcBef>
+                <a:spcPts val="0"/>
+              </a:spcBef>
+              <a:buNone/>
+            </a:pPr>
+            <a:r>
+              <a:rPr sz="1600" b="0">
+                <a:solidFill>
+                  <a:srgbClr val="9700FF"/>
+                </a:solidFill>
+              </a:rPr>
+              <a:t>Technical challenges</a:t>
+            </a:r>
+          </a:p>
+          <a:p>
+            <a:pPr lvl="1" marL="548640" indent="-219456">
+              <a:spcBef>
+                <a:spcPts val="400"/>
+              </a:spcBef>
+              <a:buFont typeface="Arial" pitchFamily="34" charset="0"/>
+              <a:buChar char="•"/>
+            </a:pPr>
+            <a:r>
+              <a:rPr sz="1250" b="1">
+                <a:solidFill>
+                  <a:srgbClr val="1F1F1F"/>
+                </a:solidFill>
+              </a:rPr>
+              <a:t>Role-based navigation guard — </a:t>
+            </a:r>
+            <a:r>
+              <a:rPr sz="1250" b="0">
+                <a:solidFill>
+                  <a:srgbClr val="1F1F1F"/>
+                </a:solidFill>
+              </a:rPr>
+              <a:t>redirecting between login, role-select and three route groups produced redirect loops; solved with a segment-aware guard that early-returns when the user is already in the correct group.</a:t>
+            </a:r>
+          </a:p>
+          <a:p>
+            <a:pPr lvl="1" marL="548640" indent="-219456">
+              <a:spcBef>
+                <a:spcPts val="400"/>
+              </a:spcBef>
+              <a:buFont typeface="Arial" pitchFamily="34" charset="0"/>
+              <a:buChar char="•"/>
+            </a:pPr>
+            <a:r>
+              <a:rPr sz="1250" b="1">
+                <a:solidFill>
+                  <a:srgbClr val="1F1F1F"/>
+                </a:solidFill>
+              </a:rPr>
+              <a:t>Backend optionality — </a:t>
+            </a:r>
+            <a:r>
+              <a:rPr sz="1250" b="0">
+                <a:solidFill>
+                  <a:srgbClr val="1F1F1F"/>
+                </a:solidFill>
+              </a:rPr>
+              <a:t>every call had to behave identically with and without Supabase, forcing all data access behind one service.</a:t>
+            </a:r>
+          </a:p>
+          <a:p>
+            <a:pPr lvl="1" marL="548640" indent="-219456">
+              <a:spcBef>
+                <a:spcPts val="400"/>
+              </a:spcBef>
+              <a:buFont typeface="Arial" pitchFamily="34" charset="0"/>
+              <a:buChar char="•"/>
+            </a:pPr>
+            <a:r>
+              <a:rPr sz="1250" b="1">
+                <a:solidFill>
+                  <a:srgbClr val="1F1F1F"/>
+                </a:solidFill>
+              </a:rPr>
+              <a:t>Web and native parity — </a:t>
+            </a:r>
+            <a:r>
+              <a:rPr sz="1250" b="0">
+                <a:solidFill>
+                  <a:srgbClr val="1F1F1F"/>
+                </a:solidFill>
+              </a:rPr>
+              <a:t>Alert.alert does not exist in the browser, so it is shimmed; the web build is constrained to a 430 px column so the phone UI is not stretched across a desktop.</a:t>
+            </a:r>
+          </a:p>
+          <a:p>
+            <a:pPr marL="0" indent="0">
+              <a:spcBef>
+                <a:spcPts val="1200"/>
+              </a:spcBef>
+              <a:buNone/>
+            </a:pPr>
+            <a:r>
+              <a:rPr sz="1600" b="0">
+                <a:solidFill>
+                  <a:srgbClr val="9700FF"/>
+                </a:solidFill>
+              </a:rPr>
+              <a:t>Known limitations</a:t>
+            </a:r>
+          </a:p>
+          <a:p>
+            <a:pPr lvl="1" marL="548640" indent="-219456">
+              <a:spcBef>
+                <a:spcPts val="400"/>
+              </a:spcBef>
+              <a:buFont typeface="Arial" pitchFamily="34" charset="0"/>
+              <a:buChar char="•"/>
+            </a:pPr>
+            <a:r>
+              <a:rPr sz="1250" b="0">
+                <a:solidFill>
+                  <a:srgbClr val="1F1F1F"/>
+                </a:solidFill>
+              </a:rPr>
+              <a:t>Payment method is selected but not settled — no gateway integration.</a:t>
+            </a:r>
+          </a:p>
+          <a:p>
+            <a:pPr lvl="1" marL="548640" indent="-219456">
+              <a:spcBef>
+                <a:spcPts val="400"/>
+              </a:spcBef>
+              <a:buFont typeface="Arial" pitchFamily="34" charset="0"/>
+              <a:buChar char="•"/>
+            </a:pPr>
+            <a:r>
+              <a:rPr sz="1250" b="0">
+                <a:solidFill>
+                  <a:srgbClr val="1F1F1F"/>
+                </a:solidFill>
+              </a:rPr>
+              <a:t>The Route screen shows pickup and drop details, not live GPS; with no push notifications, order state refreshes on screen focus.</a:t>
+            </a:r>
+          </a:p>
+          <a:p>
+            <a:pPr lvl="1" marL="548640" indent="-219456">
+              <a:spcBef>
+                <a:spcPts val="400"/>
+              </a:spcBef>
+              <a:buFont typeface="Arial" pitchFamily="34" charset="0"/>
+              <a:buChar char="•"/>
+            </a:pPr>
+            <a:r>
+              <a:rPr sz="1250" b="1">
+                <a:solidFill>
+                  <a:srgbClr val="1F1F1F"/>
+                </a:solidFill>
+              </a:rPr>
+              <a:t>Coverage is integration-level — </a:t>
+            </a:r>
+            <a:r>
+              <a:rPr sz="1250" b="0">
+                <a:solidFill>
+                  <a:srgbClr val="1F1F1F"/>
+                </a:solidFill>
+              </a:rPr>
+              <a:t>40 automated end-to-end cases drive the full three-role cycle, but there is no unit test runner yet for the pure helper functions.</a:t>
+            </a:r>
+          </a:p>
+        </p:txBody>
+      </p:sp>
+    </p:spTree>
+  </p:cSld>
+  <p:clrMapOvr>
+    <a:masterClrMapping/>
+  </p:clrMapOvr>
+</p:sld>
+</file>
+
+<file path=ppt/slides/slide11.xml><?xml version="1.0" encoding="utf-8"?>
 <p:sld xmlns:a="http://schemas.openxmlformats.org/drawingml/2006/main" xmlns:r="http://schemas.openxmlformats.org/officeDocument/2006/relationships" xmlns:p="http://schemas.openxmlformats.org/presentationml/2006/main">
   <p:cSld>
     <p:spTree>
@@ -10221,7 +10452,7 @@
 </file>
 
 <file path=ppt/slides/slide9.xml><?xml version="1.0" encoding="utf-8"?>
-<p:sld xmlns:a="http://schemas.openxmlformats.org/drawingml/2006/main" xmlns:r="http://schemas.openxmlformats.org/officeDocument/2006/relationships" xmlns:p="http://schemas.openxmlformats.org/presentationml/2006/main">
+<p:sld xmlns:a="http://schemas.openxmlformats.org/drawingml/2006/main" xmlns:p="http://schemas.openxmlformats.org/presentationml/2006/main" xmlns:r="http://schemas.openxmlformats.org/officeDocument/2006/relationships">
   <p:cSld>
     <p:spTree>
       <p:nvGrpSpPr>
@@ -10229,14 +10460,7 @@
         <p:cNvGrpSpPr/>
         <p:nvPr/>
       </p:nvGrpSpPr>
-      <p:grpSpPr>
-        <a:xfrm>
-          <a:off x="0" y="0"/>
-          <a:ext cx="0" cy="0"/>
-          <a:chOff x="0" y="0"/>
-          <a:chExt cx="0" cy="0"/>
-        </a:xfrm>
-      </p:grpSpPr>
+      <p:grpSpPr/>
       <p:sp>
         <p:nvSpPr>
           <p:cNvPr id="2" name="Title 1"/>
@@ -10247,197 +10471,196 @@
             <p:ph type="title"/>
           </p:nvPr>
         </p:nvSpPr>
-        <p:spPr/>
+        <p:spPr>
+          <a:xfrm>
+            <a:off x="331470" y="349886"/>
+            <a:ext cx="6995160" cy="930665"/>
+          </a:xfrm>
+        </p:spPr>
         <p:txBody>
           <a:bodyPr/>
           <a:lstStyle/>
           <a:p>
             <a:r>
-              <a:t>Challenges &amp; Limitations</a:t>
-            </a:r>
-          </a:p>
-        </p:txBody>
-      </p:sp>
-      <p:sp>
-        <p:nvSpPr>
-          <p:cNvPr id="3" name="Content Placeholder 2"/>
-          <p:cNvSpPr>
-            <a:spLocks noGrp="1"/>
-          </p:cNvSpPr>
-          <p:nvPr>
-            <p:ph idx="1"/>
-          </p:nvPr>
-        </p:nvSpPr>
-        <p:spPr/>
+              <a:t>Version Control Evidence</a:t>
+            </a:r>
+          </a:p>
+        </p:txBody>
+      </p:sp>
+      <p:pic>
+        <p:nvPicPr>
+          <p:cNvPr id="3" name="Picture 2" descr="gh-commits-01.png"/>
+          <p:cNvPicPr>
+            <a:picLocks noChangeAspect="1"/>
+          </p:cNvPicPr>
+          <p:nvPr/>
+        </p:nvPicPr>
+        <p:blipFill>
+          <a:blip r:embed="rId2"/>
+          <a:stretch>
+            <a:fillRect/>
+          </a:stretch>
+        </p:blipFill>
+        <p:spPr>
+          <a:xfrm>
+            <a:off x="457200" y="1481328"/>
+            <a:ext cx="3977639" cy="4005262"/>
+          </a:xfrm>
+          <a:prstGeom prst="rect">
+            <a:avLst/>
+          </a:prstGeom>
+        </p:spPr>
+      </p:pic>
+      <p:pic>
+        <p:nvPicPr>
+          <p:cNvPr id="4" name="Picture 3" descr="gh-01-repository.png"/>
+          <p:cNvPicPr>
+            <a:picLocks noChangeAspect="1"/>
+          </p:cNvPicPr>
+          <p:nvPr/>
+        </p:nvPicPr>
+        <p:blipFill>
+          <a:blip r:embed="rId3"/>
+          <a:stretch>
+            <a:fillRect/>
+          </a:stretch>
+        </p:blipFill>
+        <p:spPr>
+          <a:xfrm>
+            <a:off x="4709160" y="1481328"/>
+            <a:ext cx="3977639" cy="2486024"/>
+          </a:xfrm>
+          <a:prstGeom prst="rect">
+            <a:avLst/>
+          </a:prstGeom>
+        </p:spPr>
+      </p:pic>
+      <p:sp>
+        <p:nvSpPr>
+          <p:cNvPr id="5" name="TextBox 4"/>
+          <p:cNvSpPr txBox="1"/>
+          <p:nvPr/>
+        </p:nvSpPr>
+        <p:spPr>
+          <a:xfrm>
+            <a:off x="4709160" y="4131944"/>
+            <a:ext cx="3977639" cy="1828800"/>
+          </a:xfrm>
+          <a:prstGeom prst="rect">
+            <a:avLst/>
+          </a:prstGeom>
+          <a:noFill/>
+        </p:spPr>
         <p:txBody>
           <a:bodyPr wrap="square">
-            <a:noAutofit/>
+            <a:spAutoFit/>
           </a:bodyPr>
           <a:lstStyle/>
           <a:p>
-            <a:pPr marL="0" indent="0">
-              <a:spcBef>
-                <a:spcPts val="0"/>
-              </a:spcBef>
-              <a:buNone/>
-            </a:pPr>
-            <a:r>
-              <a:rPr sz="1600" b="0">
+            <a:pPr>
+              <a:spcAft>
+                <a:spcPts val="600"/>
+              </a:spcAft>
+            </a:pPr>
+            <a:r>
+              <a:rPr b="1" sz="1300">
+                <a:solidFill>
+                  <a:srgbClr val="1F1F1F"/>
+                </a:solidFill>
+              </a:rPr>
+              <a:t>43 commits</a:t>
+            </a:r>
+            <a:r>
+              <a:rPr sz="1300">
+                <a:solidFill>
+                  <a:srgbClr val="1F1F1F"/>
+                </a:solidFill>
+              </a:rPr>
+              <a:t> over 6 months, on </a:t>
+            </a:r>
+          </a:p>
+          <a:p>
+            <a:pPr>
+              <a:spcAft>
+                <a:spcPts val="600"/>
+              </a:spcAft>
+            </a:pPr>
+            <a:r>
+              <a:rPr b="1" sz="1300">
+                <a:solidFill>
+                  <a:srgbClr val="1F1F1F"/>
+                </a:solidFill>
+              </a:rPr>
+              <a:t>main</a:t>
+            </a:r>
+            <a:r>
+              <a:rPr sz="1300">
+                <a:solidFill>
+                  <a:srgbClr val="1F1F1F"/>
+                </a:solidFill>
+              </a:rPr>
+              <a:t> — public repository</a:t>
+            </a:r>
+          </a:p>
+          <a:p>
+            <a:pPr>
+              <a:spcAft>
+                <a:spcPts val="600"/>
+              </a:spcAft>
+            </a:pPr>
+            <a:r>
+              <a:rPr b="1" sz="1300">
+                <a:solidFill>
+                  <a:srgbClr val="1F1F1F"/>
+                </a:solidFill>
+              </a:rPr>
+              <a:t>5 contributors</a:t>
+            </a:r>
+            <a:r>
+              <a:rPr sz="1300">
+                <a:solidFill>
+                  <a:srgbClr val="1F1F1F"/>
+                </a:solidFill>
+              </a:rPr>
+              <a:t> · TypeScript 96.9%</a:t>
+            </a:r>
+          </a:p>
+          <a:p>
+            <a:pPr>
+              <a:spcAft>
+                <a:spcPts val="600"/>
+              </a:spcAft>
+            </a:pPr>
+            <a:r>
+              <a:rPr b="1" sz="1300">
+                <a:solidFill>
+                  <a:srgbClr val="1F1F1F"/>
+                </a:solidFill>
+              </a:rPr>
+              <a:t>Every feature in this deck</a:t>
+            </a:r>
+            <a:r>
+              <a:rPr sz="1300">
+                <a:solidFill>
+                  <a:srgbClr val="1F1F1F"/>
+                </a:solidFill>
+              </a:rPr>
+              <a:t> traces to a dated commit</a:t>
+            </a:r>
+          </a:p>
+          <a:p>
+            <a:pPr>
+              <a:spcAft>
+                <a:spcPts val="600"/>
+              </a:spcAft>
+            </a:pPr>
+            <a:r>
+              <a:rPr b="1" sz="1150">
                 <a:solidFill>
                   <a:srgbClr val="9700FF"/>
                 </a:solidFill>
               </a:rPr>
-              <a:t>Technical challenges</a:t>
-            </a:r>
-          </a:p>
-          <a:p>
-            <a:pPr lvl="1" marL="548640" indent="-219456">
-              <a:spcBef>
-                <a:spcPts val="400"/>
-              </a:spcBef>
-              <a:buFont typeface="Arial" pitchFamily="34" charset="0"/>
-              <a:buChar char="•"/>
-            </a:pPr>
-            <a:r>
-              <a:rPr sz="1250" b="1">
-                <a:solidFill>
-                  <a:srgbClr val="1F1F1F"/>
-                </a:solidFill>
-              </a:rPr>
-              <a:t>Role-based navigation guard — </a:t>
-            </a:r>
-            <a:r>
-              <a:rPr sz="1250" b="0">
-                <a:solidFill>
-                  <a:srgbClr val="1F1F1F"/>
-                </a:solidFill>
-              </a:rPr>
-              <a:t>redirecting between login, role-select and three route groups produced redirect loops; solved with a segment-aware guard that early-returns when the user is already in the correct group.</a:t>
-            </a:r>
-          </a:p>
-          <a:p>
-            <a:pPr lvl="1" marL="548640" indent="-219456">
-              <a:spcBef>
-                <a:spcPts val="400"/>
-              </a:spcBef>
-              <a:buFont typeface="Arial" pitchFamily="34" charset="0"/>
-              <a:buChar char="•"/>
-            </a:pPr>
-            <a:r>
-              <a:rPr sz="1250" b="1">
-                <a:solidFill>
-                  <a:srgbClr val="1F1F1F"/>
-                </a:solidFill>
-              </a:rPr>
-              <a:t>Backend optionality — </a:t>
-            </a:r>
-            <a:r>
-              <a:rPr sz="1250" b="0">
-                <a:solidFill>
-                  <a:srgbClr val="1F1F1F"/>
-                </a:solidFill>
-              </a:rPr>
-              <a:t>every call had to behave identically with and without Supabase, forcing all data access behind one service.</a:t>
-            </a:r>
-          </a:p>
-          <a:p>
-            <a:pPr lvl="1" marL="548640" indent="-219456">
-              <a:spcBef>
-                <a:spcPts val="400"/>
-              </a:spcBef>
-              <a:buFont typeface="Arial" pitchFamily="34" charset="0"/>
-              <a:buChar char="•"/>
-            </a:pPr>
-            <a:r>
-              <a:rPr sz="1250" b="1">
-                <a:solidFill>
-                  <a:srgbClr val="1F1F1F"/>
-                </a:solidFill>
-              </a:rPr>
-              <a:t>Web and native parity — </a:t>
-            </a:r>
-            <a:r>
-              <a:rPr sz="1250" b="0">
-                <a:solidFill>
-                  <a:srgbClr val="1F1F1F"/>
-                </a:solidFill>
-              </a:rPr>
-              <a:t>Alert.alert does not exist in the browser, so it is shimmed; the web build is constrained to a 430 px column so the phone UI is not stretched across a desktop.</a:t>
-            </a:r>
-          </a:p>
-          <a:p>
-            <a:pPr marL="0" indent="0">
-              <a:spcBef>
-                <a:spcPts val="1200"/>
-              </a:spcBef>
-              <a:buNone/>
-            </a:pPr>
-            <a:r>
-              <a:rPr sz="1600" b="0">
-                <a:solidFill>
-                  <a:srgbClr val="9700FF"/>
-                </a:solidFill>
-              </a:rPr>
-              <a:t>Known limitations</a:t>
-            </a:r>
-          </a:p>
-          <a:p>
-            <a:pPr lvl="1" marL="548640" indent="-219456">
-              <a:spcBef>
-                <a:spcPts val="400"/>
-              </a:spcBef>
-              <a:buFont typeface="Arial" pitchFamily="34" charset="0"/>
-              <a:buChar char="•"/>
-            </a:pPr>
-            <a:r>
-              <a:rPr sz="1250" b="0">
-                <a:solidFill>
-                  <a:srgbClr val="1F1F1F"/>
-                </a:solidFill>
-              </a:rPr>
-              <a:t>Payment method is selected but not settled — no gateway integration.</a:t>
-            </a:r>
-          </a:p>
-          <a:p>
-            <a:pPr lvl="1" marL="548640" indent="-219456">
-              <a:spcBef>
-                <a:spcPts val="400"/>
-              </a:spcBef>
-              <a:buFont typeface="Arial" pitchFamily="34" charset="0"/>
-              <a:buChar char="•"/>
-            </a:pPr>
-            <a:r>
-              <a:rPr sz="1250" b="0">
-                <a:solidFill>
-                  <a:srgbClr val="1F1F1F"/>
-                </a:solidFill>
-              </a:rPr>
-              <a:t>The Route screen shows pickup and drop details, not live GPS; with no push notifications, order state refreshes on screen focus.</a:t>
-            </a:r>
-          </a:p>
-          <a:p>
-            <a:pPr lvl="1" marL="548640" indent="-219456">
-              <a:spcBef>
-                <a:spcPts val="400"/>
-              </a:spcBef>
-              <a:buFont typeface="Arial" pitchFamily="34" charset="0"/>
-              <a:buChar char="•"/>
-            </a:pPr>
-            <a:r>
-              <a:rPr sz="1250" b="1">
-                <a:solidFill>
-                  <a:srgbClr val="1F1F1F"/>
-                </a:solidFill>
-              </a:rPr>
-              <a:t>Coverage is integration-level — </a:t>
-            </a:r>
-            <a:r>
-              <a:rPr sz="1250" b="0">
-                <a:solidFill>
-                  <a:srgbClr val="1F1F1F"/>
-                </a:solidFill>
-              </a:rPr>
-              <a:t>40 automated end-to-end cases drive the full three-role cycle, but there is no unit test runner yet for the pure helper functions.</a:t>
+              <a:t>github.com/Vijaygaurav2004/Farmer_groceries</a:t>
             </a:r>
           </a:p>
         </p:txBody>

</xml_diff>